<commit_message>
Slides: progresso dos caps. 17–24
Co-Authored-By: Claude Sonnet 5.5 <noreply@anthropic.com>
Claude-Session: https://claude.ai/code/session_01LQk7H4UNLk2VXi2CstzPTX
</commit_message>
<xml_diff>
--- a/livro_ia_educacao/saida/pptx/Cap21_slides.pptx
+++ b/livro_ia_educacao/saida/pptx/Cap21_slides.pptx
@@ -13160,7 +13160,7 @@
                 <a:ea typeface="Cambria" pitchFamily="34" charset="-122"/>
                 <a:cs typeface="Cambria" pitchFamily="34" charset="-120"/>
               </a:rPr>
-              <a:t>Interdisciplinaridade</a:t>
+              <a:t>Interdisciplinar</a:t>
             </a:r>
             <a:endParaRPr lang="en-US" sz="1800" dirty="0"/>
           </a:p>
@@ -13333,7 +13333,7 @@
                 <a:ea typeface="Cambria" pitchFamily="34" charset="-122"/>
                 <a:cs typeface="Cambria" pitchFamily="34" charset="-120"/>
               </a:rPr>
-              <a:t>Multidisciplinaridade</a:t>
+              <a:t>Multidisciplinar</a:t>
             </a:r>
             <a:endParaRPr lang="en-US" sz="1800" dirty="0"/>
           </a:p>

</xml_diff>